<commit_message>
docs: update project presentation
</commit_message>
<xml_diff>
--- a/docs/Project_Presentation.pptx
+++ b/docs/Project_Presentation.pptx
@@ -3146,7 +3146,7 @@
               <a:t>: Efrem Ion-</a:t>
             </a:r>
             <a:r>
-              <a:rPr lang="" altLang="en-US"/>
+              <a:rPr lang="en-US" altLang="en-US"/>
               <a:t>Ș</a:t>
             </a:r>
             <a:r>
@@ -3409,7 +3409,7 @@
             </a:pPr>
             <a:r>
               <a:rPr lang="en-US" altLang="en-US" sz="3200"/>
-              <a:t>Reproducible, containerized deployment</a:t>
+              <a:t>Reproductible, containerized deployment</a:t>
             </a:r>
             <a:endParaRPr lang="en-US" altLang="en-US" sz="3200"/>
           </a:p>
@@ -3775,7 +3775,7 @@
             </a:pPr>
             <a:r>
               <a:rPr lang="en-US" altLang="en-US" sz="3200">
-                <a:hlinkClick r:id="rId1" tooltip="" action="ppaction://hlinkfile"/>
+                <a:hlinkClick r:id="rId1" action="ppaction://hlinkfile"/>
               </a:rPr>
               <a:t>Github</a:t>
             </a:r>
@@ -3827,7 +3827,7 @@
               <a:t> Efrem Ion-</a:t>
             </a:r>
             <a:r>
-              <a:rPr lang="" altLang="en-US" sz="3200"/>
+              <a:rPr lang="en-US" altLang="en-US" sz="3200"/>
               <a:t>Ș</a:t>
             </a:r>
             <a:r>
@@ -5719,7 +5719,7 @@
         <p:spPr/>
         <p:txBody>
           <a:bodyPr wrap="square" lIns="274320" tIns="137160" rIns="274320" bIns="137160">
-            <a:normAutofit fontScale="90000" lnSpcReduction="10000"/>
+            <a:normAutofit/>
           </a:bodyPr>
           <a:lstStyle/>
           <a:p>
@@ -5824,91 +5824,6 @@
               </a:defRPr>
             </a:pPr>
             <a:r>
-              <a:rPr lang="en-US" altLang="en-US" b="1"/>
-              <a:t>Forecasting Accuracy</a:t>
-            </a:r>
-            <a:endParaRPr lang="en-US" altLang="en-US" b="1"/>
-          </a:p>
-          <a:p>
-            <a:pPr lvl="1">
-              <a:spcBef>
-                <a:spcPts val="100"/>
-              </a:spcBef>
-              <a:spcAft>
-                <a:spcPts val="400"/>
-              </a:spcAft>
-              <a:defRPr sz="1600">
-                <a:solidFill>
-                  <a:srgbClr val="0F2F63"/>
-                </a:solidFill>
-                <a:latin typeface="Segoe UI" panose="020B0502040204020203"/>
-              </a:defRPr>
-            </a:pPr>
-            <a:r>
-              <a:rPr lang="en-US" altLang="en-US"/>
-              <a:t>Mean Absolute Error: 15-25W (3-5% of range)</a:t>
-            </a:r>
-            <a:endParaRPr lang="en-US" altLang="en-US"/>
-          </a:p>
-          <a:p>
-            <a:pPr lvl="1">
-              <a:spcBef>
-                <a:spcPts val="100"/>
-              </a:spcBef>
-              <a:spcAft>
-                <a:spcPts val="400"/>
-              </a:spcAft>
-              <a:defRPr sz="1600">
-                <a:solidFill>
-                  <a:srgbClr val="0F2F63"/>
-                </a:solidFill>
-                <a:latin typeface="Segoe UI" panose="020B0502040204020203"/>
-              </a:defRPr>
-            </a:pPr>
-            <a:r>
-              <a:rPr lang="en-US" altLang="en-US"/>
-              <a:t>Mean Absolute Percentage Error: 5-10%</a:t>
-            </a:r>
-            <a:endParaRPr lang="en-US" altLang="en-US"/>
-          </a:p>
-          <a:p>
-            <a:pPr lvl="1">
-              <a:spcBef>
-                <a:spcPts val="100"/>
-              </a:spcBef>
-              <a:spcAft>
-                <a:spcPts val="400"/>
-              </a:spcAft>
-              <a:defRPr sz="1600">
-                <a:solidFill>
-                  <a:srgbClr val="0F2F63"/>
-                </a:solidFill>
-                <a:latin typeface="Segoe UI" panose="020B0502040204020203"/>
-              </a:defRPr>
-            </a:pPr>
-            <a:r>
-              <a:rPr lang="en-US" altLang="en-US"/>
-              <a:t>Confidence intervals: 80% prediction accuracy</a:t>
-            </a:r>
-            <a:endParaRPr lang="en-US" altLang="en-US"/>
-          </a:p>
-          <a:p>
-            <a:pPr marL="0" indent="0">
-              <a:spcBef>
-                <a:spcPts val="100"/>
-              </a:spcBef>
-              <a:spcAft>
-                <a:spcPts val="400"/>
-              </a:spcAft>
-              <a:buNone/>
-              <a:defRPr sz="1600">
-                <a:solidFill>
-                  <a:srgbClr val="0F2F63"/>
-                </a:solidFill>
-                <a:latin typeface="Segoe UI" panose="020B0502040204020203"/>
-              </a:defRPr>
-            </a:pPr>
-            <a:r>
               <a:rPr lang="en-US" altLang="en-US" sz="1600" b="1"/>
               <a:t>Edge AI Control</a:t>
             </a:r>
@@ -5931,7 +5846,7 @@
             </a:pPr>
             <a:r>
               <a:rPr lang="en-US" altLang="en-US" sz="1600"/>
-              <a:t>100% overload prevention rate</a:t>
+              <a:t>High Overload prevention rate</a:t>
             </a:r>
             <a:endParaRPr lang="en-US" altLang="en-US" sz="1600"/>
           </a:p>
@@ -5952,7 +5867,7 @@
             </a:pPr>
             <a:r>
               <a:rPr lang="en-US" altLang="en-US" sz="1600"/>
-              <a:t>&lt; 5% false positive rate</a:t>
+              <a:t>Low false positive rate</a:t>
             </a:r>
             <a:endParaRPr lang="en-US" altLang="en-US" sz="1600"/>
           </a:p>
@@ -6037,7 +5952,7 @@
             </a:pPr>
             <a:r>
               <a:rPr lang="en-US" altLang="en-US" sz="1600"/>
-              <a:t>CPU usage: &lt; 10% average</a:t>
+              <a:t>Low CPU usage</a:t>
             </a:r>
             <a:endParaRPr lang="en-US" altLang="en-US" sz="1600"/>
           </a:p>
@@ -6272,7 +6187,7 @@
             </a:pPr>
             <a:r>
               <a:rPr lang="en-US" altLang="en-US"/>
-              <a:t>1-2 minutes advance warning</a:t>
+              <a:t>Advance warning</a:t>
             </a:r>
             <a:endParaRPr lang="en-US" altLang="en-US"/>
           </a:p>

</xml_diff>